<commit_message>
Dormeo US weekly deck: week 43 inventory update
Co-Authored-By: Claude Opus 5.5 <noreply@anthropic.com>
Claude-Session: https://claude.ai/code/session_015K5QwRPUsrW7NqJSJWwuXk
</commit_message>
<xml_diff>
--- a/dormeo-us/deck/2026-10-25/Dormeo-US-Weekly-Business-Review-Week-43-2026-10-25.pptx
+++ b/dormeo-us/deck/2026-10-25/Dormeo-US-Weekly-Business-Review-Week-43-2026-10-25.pptx
@@ -6795,7 +6795,7 @@
                 </a:solidFill>
                 <a:latin typeface="Space Grotesk"/>
               </a:rPr>
-              <a:t>Stock position — week 43 inventory update (10/19/2026)</a:t>
+              <a:t>Stock position — week 44 inventory update (10/26/2026)</a:t>
             </a:r>
           </a:p>
         </p:txBody>
@@ -7040,7 +7040,7 @@
                 </a:solidFill>
                 <a:latin typeface="Inter"/>
               </a:rPr>
-              <a:t>of 19 selling SKUs, 0 at FBA</a:t>
+              <a:t>of 17 selling SKUs, 0 at FBA</a:t>
             </a:r>
           </a:p>
         </p:txBody>
@@ -7134,7 +7134,7 @@
                 </a:solidFill>
                 <a:latin typeface="Space Grotesk"/>
               </a:rPr>
-              <a:t>2</a:t>
+              <a:t>3</a:t>
             </a:r>
           </a:p>
         </p:txBody>
@@ -7263,7 +7263,7 @@
                 </a:solidFill>
                 <a:latin typeface="Space Grotesk"/>
               </a:rPr>
-              <a:t>938</a:t>
+              <a:t>1,187</a:t>
             </a:r>
           </a:p>
         </p:txBody>
@@ -7474,7 +7474,99 @@
         <p:spPr>
           <a:xfrm>
             <a:off x="5257800" y="2374925"/>
-            <a:ext cx="729081" cy="313639"/>
+            <a:ext cx="297180" cy="313639"/>
+          </a:xfrm>
+          <a:prstGeom prst="rect">
+            <a:avLst/>
+          </a:prstGeom>
+          <a:solidFill>
+            <a:srgbClr val="DC2626"/>
+          </a:solidFill>
+          <a:ln>
+            <a:noFill/>
+          </a:ln>
+        </p:spPr>
+      </p:sp>
+      <p:sp>
+        <p:nvSpPr>
+          <p:cNvPr id="28" name="Shape 28"/>
+          <p:cNvSpPr txBox="1"/>
+          <p:nvPr/>
+        </p:nvSpPr>
+        <p:spPr>
+          <a:xfrm>
+            <a:off x="5609844" y="2251710"/>
+            <a:ext cx="914400" cy="560070"/>
+          </a:xfrm>
+          <a:prstGeom prst="rect">
+            <a:avLst/>
+          </a:prstGeom>
+          <a:noFill/>
+        </p:spPr>
+        <p:txBody>
+          <a:bodyPr wrap="square" lIns="36576" rIns="36576" tIns="18288" bIns="18288" anchor="ctr">
+            <a:spAutoFit/>
+          </a:bodyPr>
+          <a:lstStyle/>
+          <a:p>
+            <a:pPr algn="l"/>
+            <a:r>
+              <a:rPr sz="1000" b="1">
+                <a:solidFill>
+                  <a:srgbClr val="0F172A"/>
+                </a:solidFill>
+                <a:latin typeface="Inter"/>
+              </a:rPr>
+              <a:t>0.7 wk</a:t>
+            </a:r>
+          </a:p>
+        </p:txBody>
+      </p:sp>
+      <p:sp>
+        <p:nvSpPr>
+          <p:cNvPr id="29" name="Shape 29"/>
+          <p:cNvSpPr txBox="1"/>
+          <p:nvPr/>
+        </p:nvSpPr>
+        <p:spPr>
+          <a:xfrm>
+            <a:off x="3429000" y="2811780"/>
+            <a:ext cx="1828800" cy="560070"/>
+          </a:xfrm>
+          <a:prstGeom prst="rect">
+            <a:avLst/>
+          </a:prstGeom>
+          <a:noFill/>
+        </p:spPr>
+        <p:txBody>
+          <a:bodyPr wrap="square" lIns="36576" rIns="36576" tIns="18288" bIns="18288" anchor="ctr">
+            <a:spAutoFit/>
+          </a:bodyPr>
+          <a:lstStyle/>
+          <a:p>
+            <a:pPr algn="l"/>
+            <a:r>
+              <a:rPr sz="1000" b="0">
+                <a:solidFill>
+                  <a:srgbClr val="0F172A"/>
+                </a:solidFill>
+                <a:latin typeface="Inter"/>
+              </a:rPr>
+              <a:t>Octaspring Full</a:t>
+            </a:r>
+          </a:p>
+        </p:txBody>
+      </p:sp>
+      <p:sp>
+        <p:nvSpPr>
+          <p:cNvPr id="30" name="Shape 30"/>
+          <p:cNvSpPr/>
+          <p:nvPr/>
+        </p:nvSpPr>
+        <p:spPr>
+          <a:xfrm>
+            <a:off x="5257800" y="2934995"/>
+            <a:ext cx="1149096" cy="313639"/>
           </a:xfrm>
           <a:prstGeom prst="rect">
             <a:avLst/>
@@ -7489,13 +7581,13 @@
       </p:sp>
       <p:sp>
         <p:nvSpPr>
-          <p:cNvPr id="28" name="Shape 28"/>
-          <p:cNvSpPr txBox="1"/>
-          <p:nvPr/>
-        </p:nvSpPr>
-        <p:spPr>
-          <a:xfrm>
-            <a:off x="6041745" y="2251710"/>
+          <p:cNvPr id="31" name="Shape 31"/>
+          <p:cNvSpPr txBox="1"/>
+          <p:nvPr/>
+        </p:nvSpPr>
+        <p:spPr>
+          <a:xfrm>
+            <a:off x="6461760" y="2811780"/>
             <a:ext cx="914400" cy="560070"/>
           </a:xfrm>
           <a:prstGeom prst="rect">
@@ -7517,20 +7609,20 @@
                 </a:solidFill>
                 <a:latin typeface="Inter"/>
               </a:rPr>
-              <a:t>1.6 wk</a:t>
-            </a:r>
-          </a:p>
-        </p:txBody>
-      </p:sp>
-      <p:sp>
-        <p:nvSpPr>
-          <p:cNvPr id="29" name="Shape 29"/>
-          <p:cNvSpPr txBox="1"/>
-          <p:nvPr/>
-        </p:nvSpPr>
-        <p:spPr>
-          <a:xfrm>
-            <a:off x="3429000" y="2811780"/>
+              <a:t>2.5 wk</a:t>
+            </a:r>
+          </a:p>
+        </p:txBody>
+      </p:sp>
+      <p:sp>
+        <p:nvSpPr>
+          <p:cNvPr id="32" name="Shape 32"/>
+          <p:cNvSpPr txBox="1"/>
+          <p:nvPr/>
+        </p:nvSpPr>
+        <p:spPr>
+          <a:xfrm>
+            <a:off x="3429000" y="3371850"/>
             <a:ext cx="1828800" cy="560070"/>
           </a:xfrm>
           <a:prstGeom prst="rect">
@@ -7552,21 +7644,21 @@
                 </a:solidFill>
                 <a:latin typeface="Inter"/>
               </a:rPr>
-              <a:t>Octaspring Full</a:t>
-            </a:r>
-          </a:p>
-        </p:txBody>
-      </p:sp>
-      <p:sp>
-        <p:nvSpPr>
-          <p:cNvPr id="30" name="Shape 30"/>
+              <a:t>Octaspring Twin &amp; XL</a:t>
+            </a:r>
+          </a:p>
+        </p:txBody>
+      </p:sp>
+      <p:sp>
+        <p:nvSpPr>
+          <p:cNvPr id="33" name="Shape 33"/>
           <p:cNvSpPr/>
           <p:nvPr/>
         </p:nvSpPr>
         <p:spPr>
           <a:xfrm>
-            <a:off x="5257800" y="2934995"/>
-            <a:ext cx="1803717" cy="313639"/>
+            <a:off x="5257800" y="3495065"/>
+            <a:ext cx="2561213" cy="313639"/>
           </a:xfrm>
           <a:prstGeom prst="rect">
             <a:avLst/>
@@ -7581,13 +7673,13 @@
       </p:sp>
       <p:sp>
         <p:nvSpPr>
-          <p:cNvPr id="31" name="Shape 31"/>
-          <p:cNvSpPr txBox="1"/>
-          <p:nvPr/>
-        </p:nvSpPr>
-        <p:spPr>
-          <a:xfrm>
-            <a:off x="7116381" y="2811780"/>
+          <p:cNvPr id="34" name="Shape 34"/>
+          <p:cNvSpPr txBox="1"/>
+          <p:nvPr/>
+        </p:nvSpPr>
+        <p:spPr>
+          <a:xfrm>
+            <a:off x="7873877" y="3371850"/>
             <a:ext cx="914400" cy="560070"/>
           </a:xfrm>
           <a:prstGeom prst="rect">
@@ -7609,20 +7701,20 @@
                 </a:solidFill>
                 <a:latin typeface="Inter"/>
               </a:rPr>
-              <a:t>4.0 wk</a:t>
-            </a:r>
-          </a:p>
-        </p:txBody>
-      </p:sp>
-      <p:sp>
-        <p:nvSpPr>
-          <p:cNvPr id="32" name="Shape 32"/>
-          <p:cNvSpPr txBox="1"/>
-          <p:nvPr/>
-        </p:nvSpPr>
-        <p:spPr>
-          <a:xfrm>
-            <a:off x="3429000" y="3371850"/>
+              <a:t>5.6 wk</a:t>
+            </a:r>
+          </a:p>
+        </p:txBody>
+      </p:sp>
+      <p:sp>
+        <p:nvSpPr>
+          <p:cNvPr id="35" name="Shape 35"/>
+          <p:cNvSpPr txBox="1"/>
+          <p:nvPr/>
+        </p:nvSpPr>
+        <p:spPr>
+          <a:xfrm>
+            <a:off x="3429000" y="3931920"/>
             <a:ext cx="1828800" cy="560070"/>
           </a:xfrm>
           <a:prstGeom prst="rect">
@@ -7644,21 +7736,113 @@
                 </a:solidFill>
                 <a:latin typeface="Inter"/>
               </a:rPr>
-              <a:t>Octaspring Twin &amp; XL</a:t>
-            </a:r>
-          </a:p>
-        </p:txBody>
-      </p:sp>
-      <p:sp>
-        <p:nvSpPr>
-          <p:cNvPr id="33" name="Shape 33"/>
+              <a:t>Octaspring Cal/Split/RV</a:t>
+            </a:r>
+          </a:p>
+        </p:txBody>
+      </p:sp>
+      <p:sp>
+        <p:nvSpPr>
+          <p:cNvPr id="36" name="Shape 36"/>
           <p:cNvSpPr/>
           <p:nvPr/>
         </p:nvSpPr>
         <p:spPr>
           <a:xfrm>
-            <a:off x="5257800" y="3495065"/>
-            <a:ext cx="2466011" cy="313639"/>
+            <a:off x="5257800" y="4055135"/>
+            <a:ext cx="1106641" cy="313639"/>
+          </a:xfrm>
+          <a:prstGeom prst="rect">
+            <a:avLst/>
+          </a:prstGeom>
+          <a:solidFill>
+            <a:srgbClr val="D97706"/>
+          </a:solidFill>
+          <a:ln>
+            <a:noFill/>
+          </a:ln>
+        </p:spPr>
+      </p:sp>
+      <p:sp>
+        <p:nvSpPr>
+          <p:cNvPr id="37" name="Shape 37"/>
+          <p:cNvSpPr txBox="1"/>
+          <p:nvPr/>
+        </p:nvSpPr>
+        <p:spPr>
+          <a:xfrm>
+            <a:off x="6419305" y="3931920"/>
+            <a:ext cx="914400" cy="560070"/>
+          </a:xfrm>
+          <a:prstGeom prst="rect">
+            <a:avLst/>
+          </a:prstGeom>
+          <a:noFill/>
+        </p:spPr>
+        <p:txBody>
+          <a:bodyPr wrap="square" lIns="36576" rIns="36576" tIns="18288" bIns="18288" anchor="ctr">
+            <a:spAutoFit/>
+          </a:bodyPr>
+          <a:lstStyle/>
+          <a:p>
+            <a:pPr algn="l"/>
+            <a:r>
+              <a:rPr sz="1000" b="1">
+                <a:solidFill>
+                  <a:srgbClr val="0F172A"/>
+                </a:solidFill>
+                <a:latin typeface="Inter"/>
+              </a:rPr>
+              <a:t>2.4 wk</a:t>
+            </a:r>
+          </a:p>
+        </p:txBody>
+      </p:sp>
+      <p:sp>
+        <p:nvSpPr>
+          <p:cNvPr id="38" name="Shape 38"/>
+          <p:cNvSpPr txBox="1"/>
+          <p:nvPr/>
+        </p:nvSpPr>
+        <p:spPr>
+          <a:xfrm>
+            <a:off x="3429000" y="4491990"/>
+            <a:ext cx="1828800" cy="560070"/>
+          </a:xfrm>
+          <a:prstGeom prst="rect">
+            <a:avLst/>
+          </a:prstGeom>
+          <a:noFill/>
+        </p:spPr>
+        <p:txBody>
+          <a:bodyPr wrap="square" lIns="36576" rIns="36576" tIns="18288" bIns="18288" anchor="ctr">
+            <a:spAutoFit/>
+          </a:bodyPr>
+          <a:lstStyle/>
+          <a:p>
+            <a:pPr algn="l"/>
+            <a:r>
+              <a:rPr sz="1000" b="0">
+                <a:solidFill>
+                  <a:srgbClr val="0F172A"/>
+                </a:solidFill>
+                <a:latin typeface="Inter"/>
+              </a:rPr>
+              <a:t>SnowTek &amp; Essentials</a:t>
+            </a:r>
+          </a:p>
+        </p:txBody>
+      </p:sp>
+      <p:sp>
+        <p:nvSpPr>
+          <p:cNvPr id="39" name="Shape 39"/>
+          <p:cNvSpPr/>
+          <p:nvPr/>
+        </p:nvSpPr>
+        <p:spPr>
+          <a:xfrm>
+            <a:off x="5257800" y="4615205"/>
+            <a:ext cx="1367028" cy="313639"/>
           </a:xfrm>
           <a:prstGeom prst="rect">
             <a:avLst/>
@@ -7673,13 +7857,13 @@
       </p:sp>
       <p:sp>
         <p:nvSpPr>
-          <p:cNvPr id="34" name="Shape 34"/>
-          <p:cNvSpPr txBox="1"/>
-          <p:nvPr/>
-        </p:nvSpPr>
-        <p:spPr>
-          <a:xfrm>
-            <a:off x="7778675" y="3371850"/>
+          <p:cNvPr id="40" name="Shape 40"/>
+          <p:cNvSpPr txBox="1"/>
+          <p:nvPr/>
+        </p:nvSpPr>
+        <p:spPr>
+          <a:xfrm>
+            <a:off x="6679692" y="4491990"/>
             <a:ext cx="914400" cy="560070"/>
           </a:xfrm>
           <a:prstGeom prst="rect">
@@ -7701,20 +7885,20 @@
                 </a:solidFill>
                 <a:latin typeface="Inter"/>
               </a:rPr>
-              <a:t>5.4 wk</a:t>
-            </a:r>
-          </a:p>
-        </p:txBody>
-      </p:sp>
-      <p:sp>
-        <p:nvSpPr>
-          <p:cNvPr id="35" name="Shape 35"/>
-          <p:cNvSpPr txBox="1"/>
-          <p:nvPr/>
-        </p:nvSpPr>
-        <p:spPr>
-          <a:xfrm>
-            <a:off x="3429000" y="3931920"/>
+              <a:t>3.0 wk</a:t>
+            </a:r>
+          </a:p>
+        </p:txBody>
+      </p:sp>
+      <p:sp>
+        <p:nvSpPr>
+          <p:cNvPr id="41" name="Shape 41"/>
+          <p:cNvSpPr txBox="1"/>
+          <p:nvPr/>
+        </p:nvSpPr>
+        <p:spPr>
+          <a:xfrm>
+            <a:off x="3429000" y="5052060"/>
             <a:ext cx="1828800" cy="560070"/>
           </a:xfrm>
           <a:prstGeom prst="rect">
@@ -7736,21 +7920,21 @@
                 </a:solidFill>
                 <a:latin typeface="Inter"/>
               </a:rPr>
-              <a:t>Octaspring Cal/Split/RV</a:t>
-            </a:r>
-          </a:p>
-        </p:txBody>
-      </p:sp>
-      <p:sp>
-        <p:nvSpPr>
-          <p:cNvPr id="36" name="Shape 36"/>
+              <a:t>Pillows</a:t>
+            </a:r>
+          </a:p>
+        </p:txBody>
+      </p:sp>
+      <p:sp>
+        <p:nvSpPr>
+          <p:cNvPr id="42" name="Shape 42"/>
           <p:cNvSpPr/>
           <p:nvPr/>
         </p:nvSpPr>
         <p:spPr>
           <a:xfrm>
-            <a:off x="5257800" y="4055135"/>
-            <a:ext cx="1245514" cy="313639"/>
+            <a:off x="5257800" y="5175275"/>
+            <a:ext cx="777329" cy="313639"/>
           </a:xfrm>
           <a:prstGeom prst="rect">
             <a:avLst/>
@@ -7765,13 +7949,13 @@
       </p:sp>
       <p:sp>
         <p:nvSpPr>
-          <p:cNvPr id="37" name="Shape 37"/>
-          <p:cNvSpPr txBox="1"/>
-          <p:nvPr/>
-        </p:nvSpPr>
-        <p:spPr>
-          <a:xfrm>
-            <a:off x="6558178" y="3931920"/>
+          <p:cNvPr id="43" name="Shape 43"/>
+          <p:cNvSpPr txBox="1"/>
+          <p:nvPr/>
+        </p:nvSpPr>
+        <p:spPr>
+          <a:xfrm>
+            <a:off x="6089993" y="5052060"/>
             <a:ext cx="914400" cy="560070"/>
           </a:xfrm>
           <a:prstGeom prst="rect">
@@ -7793,191 +7977,7 @@
                 </a:solidFill>
                 <a:latin typeface="Inter"/>
               </a:rPr>
-              <a:t>2.7 wk</a:t>
-            </a:r>
-          </a:p>
-        </p:txBody>
-      </p:sp>
-      <p:sp>
-        <p:nvSpPr>
-          <p:cNvPr id="38" name="Shape 38"/>
-          <p:cNvSpPr txBox="1"/>
-          <p:nvPr/>
-        </p:nvSpPr>
-        <p:spPr>
-          <a:xfrm>
-            <a:off x="3429000" y="4491990"/>
-            <a:ext cx="1828800" cy="560070"/>
-          </a:xfrm>
-          <a:prstGeom prst="rect">
-            <a:avLst/>
-          </a:prstGeom>
-          <a:noFill/>
-        </p:spPr>
-        <p:txBody>
-          <a:bodyPr wrap="square" lIns="36576" rIns="36576" tIns="18288" bIns="18288" anchor="ctr">
-            <a:spAutoFit/>
-          </a:bodyPr>
-          <a:lstStyle/>
-          <a:p>
-            <a:pPr algn="l"/>
-            <a:r>
-              <a:rPr sz="1000" b="0">
-                <a:solidFill>
-                  <a:srgbClr val="0F172A"/>
-                </a:solidFill>
-                <a:latin typeface="Inter"/>
-              </a:rPr>
-              <a:t>SnowTek &amp; Essentials</a:t>
-            </a:r>
-          </a:p>
-        </p:txBody>
-      </p:sp>
-      <p:sp>
-        <p:nvSpPr>
-          <p:cNvPr id="39" name="Shape 39"/>
-          <p:cNvSpPr/>
-          <p:nvPr/>
-        </p:nvSpPr>
-        <p:spPr>
-          <a:xfrm>
-            <a:off x="5257800" y="4615205"/>
-            <a:ext cx="2408573" cy="313639"/>
-          </a:xfrm>
-          <a:prstGeom prst="rect">
-            <a:avLst/>
-          </a:prstGeom>
-          <a:solidFill>
-            <a:srgbClr val="2447FF"/>
-          </a:solidFill>
-          <a:ln>
-            <a:noFill/>
-          </a:ln>
-        </p:spPr>
-      </p:sp>
-      <p:sp>
-        <p:nvSpPr>
-          <p:cNvPr id="40" name="Shape 40"/>
-          <p:cNvSpPr txBox="1"/>
-          <p:nvPr/>
-        </p:nvSpPr>
-        <p:spPr>
-          <a:xfrm>
-            <a:off x="7721237" y="4491990"/>
-            <a:ext cx="914400" cy="560070"/>
-          </a:xfrm>
-          <a:prstGeom prst="rect">
-            <a:avLst/>
-          </a:prstGeom>
-          <a:noFill/>
-        </p:spPr>
-        <p:txBody>
-          <a:bodyPr wrap="square" lIns="36576" rIns="36576" tIns="18288" bIns="18288" anchor="ctr">
-            <a:spAutoFit/>
-          </a:bodyPr>
-          <a:lstStyle/>
-          <a:p>
-            <a:pPr algn="l"/>
-            <a:r>
-              <a:rPr sz="1000" b="1">
-                <a:solidFill>
-                  <a:srgbClr val="0F172A"/>
-                </a:solidFill>
-                <a:latin typeface="Inter"/>
-              </a:rPr>
-              <a:t>5.3 wk</a:t>
-            </a:r>
-          </a:p>
-        </p:txBody>
-      </p:sp>
-      <p:sp>
-        <p:nvSpPr>
-          <p:cNvPr id="41" name="Shape 41"/>
-          <p:cNvSpPr txBox="1"/>
-          <p:nvPr/>
-        </p:nvSpPr>
-        <p:spPr>
-          <a:xfrm>
-            <a:off x="3429000" y="5052060"/>
-            <a:ext cx="1828800" cy="560070"/>
-          </a:xfrm>
-          <a:prstGeom prst="rect">
-            <a:avLst/>
-          </a:prstGeom>
-          <a:noFill/>
-        </p:spPr>
-        <p:txBody>
-          <a:bodyPr wrap="square" lIns="36576" rIns="36576" tIns="18288" bIns="18288" anchor="ctr">
-            <a:spAutoFit/>
-          </a:bodyPr>
-          <a:lstStyle/>
-          <a:p>
-            <a:pPr algn="l"/>
-            <a:r>
-              <a:rPr sz="1000" b="0">
-                <a:solidFill>
-                  <a:srgbClr val="0F172A"/>
-                </a:solidFill>
-                <a:latin typeface="Inter"/>
-              </a:rPr>
-              <a:t>Pillows</a:t>
-            </a:r>
-          </a:p>
-        </p:txBody>
-      </p:sp>
-      <p:sp>
-        <p:nvSpPr>
-          <p:cNvPr id="42" name="Shape 42"/>
-          <p:cNvSpPr/>
-          <p:nvPr/>
-        </p:nvSpPr>
-        <p:spPr>
-          <a:xfrm>
-            <a:off x="5257800" y="5175275"/>
-            <a:ext cx="1053750" cy="313639"/>
-          </a:xfrm>
-          <a:prstGeom prst="rect">
-            <a:avLst/>
-          </a:prstGeom>
-          <a:solidFill>
-            <a:srgbClr val="D97706"/>
-          </a:solidFill>
-          <a:ln>
-            <a:noFill/>
-          </a:ln>
-        </p:spPr>
-      </p:sp>
-      <p:sp>
-        <p:nvSpPr>
-          <p:cNvPr id="43" name="Shape 43"/>
-          <p:cNvSpPr txBox="1"/>
-          <p:nvPr/>
-        </p:nvSpPr>
-        <p:spPr>
-          <a:xfrm>
-            <a:off x="6366414" y="5052060"/>
-            <a:ext cx="914400" cy="560070"/>
-          </a:xfrm>
-          <a:prstGeom prst="rect">
-            <a:avLst/>
-          </a:prstGeom>
-          <a:noFill/>
-        </p:spPr>
-        <p:txBody>
-          <a:bodyPr wrap="square" lIns="36576" rIns="36576" tIns="18288" bIns="18288" anchor="ctr">
-            <a:spAutoFit/>
-          </a:bodyPr>
-          <a:lstStyle/>
-          <a:p>
-            <a:pPr algn="l"/>
-            <a:r>
-              <a:rPr sz="1000" b="1">
-                <a:solidFill>
-                  <a:srgbClr val="0F172A"/>
-                </a:solidFill>
-                <a:latin typeface="Inter"/>
-              </a:rPr>
-              <a:t>2.3 wk</a:t>
+              <a:t>1.7 wk</a:t>
             </a:r>
           </a:p>
         </p:txBody>

</xml_diff>